<commit_message>
docs(pitch): showcase the 4 fintech layers + fairness, export PDF, align gate
A) Pitch narrative now reflects what's actually built:
   - pitch.md: new "Da decisão à ação" slide (segmentation, multi-channel, NBA,
     responsible AI) + evidence slide now cites fairness value disparity (0.24).
   - Deck PPTX: added a styled "Orquestração fintech" slide (S08, matches the
     dark theme, 2x2 cards) and re-stamped footer page numbers (now 23 slides).
B) mlops-lifecycle approval gate: added value-disparity criterion (<=0.30)
   alongside exposure (<=0.25), matching the model card.
C) Exported the deck to PDF (docs/Adaptive-Offers-Pitch-Grupo74.pdf, 23 pages)
   so the pitch is versioned in PDF per Etapa 8.

Co-Authored-By: Claude Opus 4.8 <noreply@anthropic.com>
</commit_message>
<xml_diff>
--- a/docs/Adaptive-Offers-Pitch-Grupo74.pptx
+++ b/docs/Adaptive-Offers-Pitch-Grupo74.pptx
@@ -12,6 +12,7 @@
     <p:sldId id="260" r:id="rId6"/>
     <p:sldId id="261" r:id="rId7"/>
     <p:sldId id="262" r:id="rId8"/>
+    <p:sldId id="279" r:id="rId30"/>
     <p:sldId id="263" r:id="rId9"/>
     <p:sldId id="264" r:id="rId10"/>
     <p:sldId id="265" r:id="rId11"/>
@@ -4429,7 +4430,7 @@
                 <a:ea typeface="Consolas" pitchFamily="34" charset="-122"/>
                 <a:cs typeface="Consolas" pitchFamily="34" charset="-120"/>
               </a:rPr>
-              <a:t>10</a:t>
+              <a:t>11</a:t>
             </a:r>
             <a:endParaRPr lang="en-US" sz="850" dirty="0"/>
           </a:p>
@@ -5673,7 +5674,7 @@
                 <a:ea typeface="Consolas" pitchFamily="34" charset="-122"/>
                 <a:cs typeface="Consolas" pitchFamily="34" charset="-120"/>
               </a:rPr>
-              <a:t>11</a:t>
+              <a:t>12</a:t>
             </a:r>
             <a:endParaRPr lang="en-US" sz="850" dirty="0"/>
           </a:p>
@@ -7098,7 +7099,7 @@
                 <a:ea typeface="Consolas" pitchFamily="34" charset="-122"/>
                 <a:cs typeface="Consolas" pitchFamily="34" charset="-120"/>
               </a:rPr>
-              <a:t>12</a:t>
+              <a:t>13</a:t>
             </a:r>
             <a:endParaRPr lang="en-US" sz="850" dirty="0"/>
           </a:p>
@@ -7766,7 +7767,7 @@
                 <a:ea typeface="Consolas" pitchFamily="34" charset="-122"/>
                 <a:cs typeface="Consolas" pitchFamily="34" charset="-120"/>
               </a:rPr>
-              <a:t>13</a:t>
+              <a:t>14</a:t>
             </a:r>
             <a:endParaRPr lang="en-US" sz="850" dirty="0"/>
           </a:p>
@@ -8319,7 +8320,7 @@
                 <a:ea typeface="Consolas" pitchFamily="34" charset="-122"/>
                 <a:cs typeface="Consolas" pitchFamily="34" charset="-120"/>
               </a:rPr>
-              <a:t>14</a:t>
+              <a:t>15</a:t>
             </a:r>
             <a:endParaRPr lang="en-US" sz="850" dirty="0"/>
           </a:p>
@@ -8872,7 +8873,7 @@
                 <a:ea typeface="Consolas" pitchFamily="34" charset="-122"/>
                 <a:cs typeface="Consolas" pitchFamily="34" charset="-120"/>
               </a:rPr>
-              <a:t>15</a:t>
+              <a:t>16</a:t>
             </a:r>
             <a:endParaRPr lang="en-US" sz="850" dirty="0"/>
           </a:p>
@@ -9425,7 +9426,7 @@
                 <a:ea typeface="Consolas" pitchFamily="34" charset="-122"/>
                 <a:cs typeface="Consolas" pitchFamily="34" charset="-120"/>
               </a:rPr>
-              <a:t>16</a:t>
+              <a:t>17</a:t>
             </a:r>
             <a:endParaRPr lang="en-US" sz="850" dirty="0"/>
           </a:p>
@@ -9978,7 +9979,7 @@
                 <a:ea typeface="Consolas" pitchFamily="34" charset="-122"/>
                 <a:cs typeface="Consolas" pitchFamily="34" charset="-120"/>
               </a:rPr>
-              <a:t>17</a:t>
+              <a:t>18</a:t>
             </a:r>
             <a:endParaRPr lang="en-US" sz="850" dirty="0"/>
           </a:p>
@@ -10531,7 +10532,7 @@
                 <a:ea typeface="Consolas" pitchFamily="34" charset="-122"/>
                 <a:cs typeface="Consolas" pitchFamily="34" charset="-120"/>
               </a:rPr>
-              <a:t>18</a:t>
+              <a:t>19</a:t>
             </a:r>
             <a:endParaRPr lang="en-US" sz="850" dirty="0"/>
           </a:p>
@@ -18024,6 +18025,978 @@
 </p:sld>
 </file>
 
+<file path=ppt/slides/slide23.xml><?xml version="1.0" encoding="utf-8"?>
+<p:sld xmlns:a="http://schemas.openxmlformats.org/drawingml/2006/main" xmlns:p="http://schemas.openxmlformats.org/presentationml/2006/main" xmlns:r="http://schemas.openxmlformats.org/officeDocument/2006/relationships">
+  <p:cSld>
+    <p:bg>
+      <p:bgPr>
+        <a:solidFill>
+          <a:srgbClr val="000000"/>
+        </a:solidFill>
+        <a:effectLst/>
+      </p:bgPr>
+    </p:bg>
+    <p:spTree>
+      <p:nvGrpSpPr>
+        <p:cNvPr id="1" name=""/>
+        <p:cNvGrpSpPr/>
+        <p:nvPr/>
+      </p:nvGrpSpPr>
+      <p:grpSpPr/>
+      <p:sp>
+        <p:nvSpPr>
+          <p:cNvPr id="2" name="TextBox 1"/>
+          <p:cNvSpPr txBox="1"/>
+          <p:nvPr/>
+        </p:nvSpPr>
+        <p:spPr>
+          <a:xfrm>
+            <a:off x="566928" y="566928"/>
+            <a:ext cx="10058400" cy="292608"/>
+          </a:xfrm>
+          <a:prstGeom prst="rect">
+            <a:avLst/>
+          </a:prstGeom>
+          <a:noFill/>
+        </p:spPr>
+        <p:txBody>
+          <a:bodyPr wrap="square" anchor="t" lIns="0" rIns="0" tIns="0" bIns="0">
+            <a:spAutoFit/>
+          </a:bodyPr>
+          <a:lstStyle/>
+          <a:p>
+            <a:pPr algn="l"/>
+            <a:r>
+              <a:rPr sz="1150" b="1" i="0" spc="300">
+                <a:solidFill>
+                  <a:srgbClr val="3291FF"/>
+                </a:solidFill>
+                <a:latin typeface="Consolas"/>
+              </a:rPr>
+              <a:t>DA DECISÃO À AÇÃO · ORQUESTRAÇÃO FINTECH</a:t>
+            </a:r>
+          </a:p>
+        </p:txBody>
+      </p:sp>
+      <p:sp>
+        <p:nvSpPr>
+          <p:cNvPr id="3" name="TextBox 2"/>
+          <p:cNvSpPr txBox="1"/>
+          <p:nvPr/>
+        </p:nvSpPr>
+        <p:spPr>
+          <a:xfrm>
+            <a:off x="566928" y="896112"/>
+            <a:ext cx="11064240" cy="914400"/>
+          </a:xfrm>
+          <a:prstGeom prst="rect">
+            <a:avLst/>
+          </a:prstGeom>
+          <a:noFill/>
+        </p:spPr>
+        <p:txBody>
+          <a:bodyPr wrap="square" anchor="t" lIns="0" rIns="0" tIns="0" bIns="0">
+            <a:spAutoFit/>
+          </a:bodyPr>
+          <a:lstStyle/>
+          <a:p>
+            <a:pPr algn="l"/>
+            <a:r>
+              <a:rPr sz="3000" b="1" i="0">
+                <a:solidFill>
+                  <a:srgbClr val="EDEDED"/>
+                </a:solidFill>
+                <a:latin typeface="Trebuchet MS"/>
+              </a:rPr>
+              <a:t>Oferta → canal → mensagem → próximo passo</a:t>
+            </a:r>
+          </a:p>
+        </p:txBody>
+      </p:sp>
+      <p:sp>
+        <p:nvSpPr>
+          <p:cNvPr id="4" name="TextBox 3"/>
+          <p:cNvSpPr txBox="1"/>
+          <p:nvPr/>
+        </p:nvSpPr>
+        <p:spPr>
+          <a:xfrm>
+            <a:off x="566928" y="1517904"/>
+            <a:ext cx="11064240" cy="457200"/>
+          </a:xfrm>
+          <a:prstGeom prst="rect">
+            <a:avLst/>
+          </a:prstGeom>
+          <a:noFill/>
+        </p:spPr>
+        <p:txBody>
+          <a:bodyPr wrap="square" anchor="t" lIns="0" rIns="0" tIns="0" bIns="0">
+            <a:spAutoFit/>
+          </a:bodyPr>
+          <a:lstStyle/>
+          <a:p>
+            <a:pPr algn="l"/>
+            <a:r>
+              <a:rPr sz="1350" b="0" i="0">
+                <a:solidFill>
+                  <a:srgbClr val="9A9AA6"/>
+                </a:solidFill>
+                <a:latin typeface="Calibri"/>
+              </a:rPr>
+              <a:t>O bandit decide </a:t>
+            </a:r>
+            <a:r>
+              <a:rPr sz="1350" b="1" i="1">
+                <a:solidFill>
+                  <a:srgbClr val="3291FF"/>
+                </a:solidFill>
+                <a:latin typeface="Calibri"/>
+              </a:rPr>
+              <a:t>o quê</a:t>
+            </a:r>
+            <a:r>
+              <a:rPr sz="1350" b="0" i="0">
+                <a:solidFill>
+                  <a:srgbClr val="9A9AA6"/>
+                </a:solidFill>
+                <a:latin typeface="Calibri"/>
+              </a:rPr>
+              <a:t>; quatro camadas determinísticas decidem </a:t>
+            </a:r>
+            <a:r>
+              <a:rPr sz="1350" b="1" i="1">
+                <a:solidFill>
+                  <a:srgbClr val="3291FF"/>
+                </a:solidFill>
+                <a:latin typeface="Calibri"/>
+              </a:rPr>
+              <a:t>onde, como e o próximo passo</a:t>
+            </a:r>
+            <a:r>
+              <a:rPr sz="1350" b="0" i="0">
+                <a:solidFill>
+                  <a:srgbClr val="9A9AA6"/>
+                </a:solidFill>
+                <a:latin typeface="Calibri"/>
+              </a:rPr>
+              <a:t>.</a:t>
+            </a:r>
+          </a:p>
+        </p:txBody>
+      </p:sp>
+      <p:sp>
+        <p:nvSpPr>
+          <p:cNvPr id="5" name="Rounded Rectangle 4"/>
+          <p:cNvSpPr/>
+          <p:nvPr/>
+        </p:nvSpPr>
+        <p:spPr>
+          <a:xfrm>
+            <a:off x="566928" y="2084831"/>
+            <a:ext cx="5353812" cy="1847088"/>
+          </a:xfrm>
+          <a:prstGeom prst="roundRect">
+            <a:avLst>
+              <a:gd name="adj" fmla="val 6000"/>
+            </a:avLst>
+          </a:prstGeom>
+          <a:solidFill>
+            <a:srgbClr val="0C0C0E"/>
+          </a:solidFill>
+          <a:ln w="12700">
+            <a:solidFill>
+              <a:srgbClr val="2A2A30"/>
+            </a:solidFill>
+          </a:ln>
+          <a:effectLst/>
+        </p:spPr>
+        <p:style>
+          <a:lnRef idx="1">
+            <a:schemeClr val="accent1"/>
+          </a:lnRef>
+          <a:fillRef idx="3">
+            <a:schemeClr val="accent1"/>
+          </a:fillRef>
+          <a:effectRef idx="2">
+            <a:schemeClr val="accent1"/>
+          </a:effectRef>
+          <a:fontRef idx="minor">
+            <a:schemeClr val="lt1"/>
+          </a:fontRef>
+        </p:style>
+        <p:txBody>
+          <a:bodyPr rtlCol="0" anchor="ctr"/>
+          <a:lstStyle/>
+          <a:p>
+            <a:pPr algn="ctr"/>
+          </a:p>
+        </p:txBody>
+      </p:sp>
+      <p:sp>
+        <p:nvSpPr>
+          <p:cNvPr id="6" name="Oval 5"/>
+          <p:cNvSpPr/>
+          <p:nvPr/>
+        </p:nvSpPr>
+        <p:spPr>
+          <a:xfrm>
+            <a:off x="859536" y="2395727"/>
+            <a:ext cx="182880" cy="182880"/>
+          </a:xfrm>
+          <a:prstGeom prst="ellipse">
+            <a:avLst/>
+          </a:prstGeom>
+          <a:solidFill>
+            <a:srgbClr val="0070F3"/>
+          </a:solidFill>
+          <a:ln>
+            <a:noFill/>
+          </a:ln>
+          <a:effectLst/>
+        </p:spPr>
+        <p:style>
+          <a:lnRef idx="1">
+            <a:schemeClr val="accent1"/>
+          </a:lnRef>
+          <a:fillRef idx="3">
+            <a:schemeClr val="accent1"/>
+          </a:fillRef>
+          <a:effectRef idx="2">
+            <a:schemeClr val="accent1"/>
+          </a:effectRef>
+          <a:fontRef idx="minor">
+            <a:schemeClr val="lt1"/>
+          </a:fontRef>
+        </p:style>
+        <p:txBody>
+          <a:bodyPr rtlCol="0" anchor="ctr"/>
+          <a:lstStyle/>
+          <a:p>
+            <a:pPr algn="ctr"/>
+          </a:p>
+        </p:txBody>
+      </p:sp>
+      <p:sp>
+        <p:nvSpPr>
+          <p:cNvPr id="7" name="TextBox 6"/>
+          <p:cNvSpPr txBox="1"/>
+          <p:nvPr/>
+        </p:nvSpPr>
+        <p:spPr>
+          <a:xfrm>
+            <a:off x="1170432" y="2322576"/>
+            <a:ext cx="4439412" cy="457200"/>
+          </a:xfrm>
+          <a:prstGeom prst="rect">
+            <a:avLst/>
+          </a:prstGeom>
+          <a:noFill/>
+        </p:spPr>
+        <p:txBody>
+          <a:bodyPr wrap="square" anchor="ctr" lIns="0" rIns="0" tIns="0" bIns="0">
+            <a:spAutoFit/>
+          </a:bodyPr>
+          <a:lstStyle/>
+          <a:p>
+            <a:pPr algn="l"/>
+            <a:r>
+              <a:rPr sz="1200" b="1" i="0">
+                <a:solidFill>
+                  <a:srgbClr val="0070F3"/>
+                </a:solidFill>
+                <a:latin typeface="Trebuchet MS"/>
+              </a:rPr>
+              <a:t>1</a:t>
+            </a:r>
+            <a:r>
+              <a:rPr sz="1600" b="1" i="0">
+                <a:solidFill>
+                  <a:srgbClr val="EDEDED"/>
+                </a:solidFill>
+                <a:latin typeface="Trebuchet MS"/>
+              </a:rPr>
+              <a:t>  Segmentação comportamental</a:t>
+            </a:r>
+          </a:p>
+        </p:txBody>
+      </p:sp>
+      <p:sp>
+        <p:nvSpPr>
+          <p:cNvPr id="8" name="TextBox 7"/>
+          <p:cNvSpPr txBox="1"/>
+          <p:nvPr/>
+        </p:nvSpPr>
+        <p:spPr>
+          <a:xfrm>
+            <a:off x="877824" y="2926079"/>
+            <a:ext cx="4750307" cy="914400"/>
+          </a:xfrm>
+          <a:prstGeom prst="rect">
+            <a:avLst/>
+          </a:prstGeom>
+          <a:noFill/>
+        </p:spPr>
+        <p:txBody>
+          <a:bodyPr wrap="square" anchor="t" lIns="0" rIns="0" tIns="0" bIns="0">
+            <a:spAutoFit/>
+          </a:bodyPr>
+          <a:lstStyle/>
+          <a:p>
+            <a:pPr algn="l">
+              <a:lnSpc>
+                <a:spcPct val="106000"/>
+              </a:lnSpc>
+            </a:pPr>
+            <a:r>
+              <a:rPr sz="1250" b="0" i="0">
+                <a:solidFill>
+                  <a:srgbClr val="9A9AA6"/>
+                </a:solidFill>
+                <a:latin typeface="Calibri"/>
+              </a:rPr>
+              <a:t>6 personas determinísticas das features reais (renegociador, sênior, jovem digital…). Leitura humana do book de clientes.</a:t>
+            </a:r>
+          </a:p>
+        </p:txBody>
+      </p:sp>
+      <p:sp>
+        <p:nvSpPr>
+          <p:cNvPr id="9" name="Rounded Rectangle 8"/>
+          <p:cNvSpPr/>
+          <p:nvPr/>
+        </p:nvSpPr>
+        <p:spPr>
+          <a:xfrm>
+            <a:off x="6268212" y="2084831"/>
+            <a:ext cx="5353812" cy="1847088"/>
+          </a:xfrm>
+          <a:prstGeom prst="roundRect">
+            <a:avLst>
+              <a:gd name="adj" fmla="val 6000"/>
+            </a:avLst>
+          </a:prstGeom>
+          <a:solidFill>
+            <a:srgbClr val="0C0C0E"/>
+          </a:solidFill>
+          <a:ln w="12700">
+            <a:solidFill>
+              <a:srgbClr val="2A2A30"/>
+            </a:solidFill>
+          </a:ln>
+          <a:effectLst/>
+        </p:spPr>
+        <p:style>
+          <a:lnRef idx="1">
+            <a:schemeClr val="accent1"/>
+          </a:lnRef>
+          <a:fillRef idx="3">
+            <a:schemeClr val="accent1"/>
+          </a:fillRef>
+          <a:effectRef idx="2">
+            <a:schemeClr val="accent1"/>
+          </a:effectRef>
+          <a:fontRef idx="minor">
+            <a:schemeClr val="lt1"/>
+          </a:fontRef>
+        </p:style>
+        <p:txBody>
+          <a:bodyPr rtlCol="0" anchor="ctr"/>
+          <a:lstStyle/>
+          <a:p>
+            <a:pPr algn="ctr"/>
+          </a:p>
+        </p:txBody>
+      </p:sp>
+      <p:sp>
+        <p:nvSpPr>
+          <p:cNvPr id="10" name="Oval 9"/>
+          <p:cNvSpPr/>
+          <p:nvPr/>
+        </p:nvSpPr>
+        <p:spPr>
+          <a:xfrm>
+            <a:off x="6560820" y="2395727"/>
+            <a:ext cx="182880" cy="182880"/>
+          </a:xfrm>
+          <a:prstGeom prst="ellipse">
+            <a:avLst/>
+          </a:prstGeom>
+          <a:solidFill>
+            <a:srgbClr val="34D399"/>
+          </a:solidFill>
+          <a:ln>
+            <a:noFill/>
+          </a:ln>
+          <a:effectLst/>
+        </p:spPr>
+        <p:style>
+          <a:lnRef idx="1">
+            <a:schemeClr val="accent1"/>
+          </a:lnRef>
+          <a:fillRef idx="3">
+            <a:schemeClr val="accent1"/>
+          </a:fillRef>
+          <a:effectRef idx="2">
+            <a:schemeClr val="accent1"/>
+          </a:effectRef>
+          <a:fontRef idx="minor">
+            <a:schemeClr val="lt1"/>
+          </a:fontRef>
+        </p:style>
+        <p:txBody>
+          <a:bodyPr rtlCol="0" anchor="ctr"/>
+          <a:lstStyle/>
+          <a:p>
+            <a:pPr algn="ctr"/>
+          </a:p>
+        </p:txBody>
+      </p:sp>
+      <p:sp>
+        <p:nvSpPr>
+          <p:cNvPr id="11" name="TextBox 10"/>
+          <p:cNvSpPr txBox="1"/>
+          <p:nvPr/>
+        </p:nvSpPr>
+        <p:spPr>
+          <a:xfrm>
+            <a:off x="6871716" y="2322576"/>
+            <a:ext cx="4439412" cy="457200"/>
+          </a:xfrm>
+          <a:prstGeom prst="rect">
+            <a:avLst/>
+          </a:prstGeom>
+          <a:noFill/>
+        </p:spPr>
+        <p:txBody>
+          <a:bodyPr wrap="square" anchor="ctr" lIns="0" rIns="0" tIns="0" bIns="0">
+            <a:spAutoFit/>
+          </a:bodyPr>
+          <a:lstStyle/>
+          <a:p>
+            <a:pPr algn="l"/>
+            <a:r>
+              <a:rPr sz="1200" b="1" i="0">
+                <a:solidFill>
+                  <a:srgbClr val="34D399"/>
+                </a:solidFill>
+                <a:latin typeface="Trebuchet MS"/>
+              </a:rPr>
+              <a:t>2</a:t>
+            </a:r>
+            <a:r>
+              <a:rPr sz="1600" b="1" i="0">
+                <a:solidFill>
+                  <a:srgbClr val="EDEDED"/>
+                </a:solidFill>
+                <a:latin typeface="Trebuchet MS"/>
+              </a:rPr>
+              <a:t>  Orquestração multi-canal</a:t>
+            </a:r>
+          </a:p>
+        </p:txBody>
+      </p:sp>
+      <p:sp>
+        <p:nvSpPr>
+          <p:cNvPr id="12" name="TextBox 11"/>
+          <p:cNvSpPr txBox="1"/>
+          <p:nvPr/>
+        </p:nvSpPr>
+        <p:spPr>
+          <a:xfrm>
+            <a:off x="6579107" y="2926079"/>
+            <a:ext cx="4750307" cy="914400"/>
+          </a:xfrm>
+          <a:prstGeom prst="rect">
+            <a:avLst/>
+          </a:prstGeom>
+          <a:noFill/>
+        </p:spPr>
+        <p:txBody>
+          <a:bodyPr wrap="square" anchor="t" lIns="0" rIns="0" tIns="0" bIns="0">
+            <a:spAutoFit/>
+          </a:bodyPr>
+          <a:lstStyle/>
+          <a:p>
+            <a:pPr algn="l">
+              <a:lnSpc>
+                <a:spcPct val="106000"/>
+              </a:lnSpc>
+            </a:pPr>
+            <a:r>
+              <a:rPr sz="1250" b="0" i="0">
+                <a:solidFill>
+                  <a:srgbClr val="9A9AA6"/>
+                </a:solidFill>
+                <a:latin typeface="Calibri"/>
+              </a:rPr>
+              <a:t>App push · e-mail · SMS · voz com frequency cap e horário de silêncio. Guardrail auditável com reason codes.</a:t>
+            </a:r>
+          </a:p>
+        </p:txBody>
+      </p:sp>
+      <p:sp>
+        <p:nvSpPr>
+          <p:cNvPr id="13" name="Rounded Rectangle 12"/>
+          <p:cNvSpPr/>
+          <p:nvPr/>
+        </p:nvSpPr>
+        <p:spPr>
+          <a:xfrm>
+            <a:off x="566928" y="4187952"/>
+            <a:ext cx="5353812" cy="1847088"/>
+          </a:xfrm>
+          <a:prstGeom prst="roundRect">
+            <a:avLst>
+              <a:gd name="adj" fmla="val 6000"/>
+            </a:avLst>
+          </a:prstGeom>
+          <a:solidFill>
+            <a:srgbClr val="0C0C0E"/>
+          </a:solidFill>
+          <a:ln w="12700">
+            <a:solidFill>
+              <a:srgbClr val="2A2A30"/>
+            </a:solidFill>
+          </a:ln>
+          <a:effectLst/>
+        </p:spPr>
+        <p:style>
+          <a:lnRef idx="1">
+            <a:schemeClr val="accent1"/>
+          </a:lnRef>
+          <a:fillRef idx="3">
+            <a:schemeClr val="accent1"/>
+          </a:fillRef>
+          <a:effectRef idx="2">
+            <a:schemeClr val="accent1"/>
+          </a:effectRef>
+          <a:fontRef idx="minor">
+            <a:schemeClr val="lt1"/>
+          </a:fontRef>
+        </p:style>
+        <p:txBody>
+          <a:bodyPr rtlCol="0" anchor="ctr"/>
+          <a:lstStyle/>
+          <a:p>
+            <a:pPr algn="ctr"/>
+          </a:p>
+        </p:txBody>
+      </p:sp>
+      <p:sp>
+        <p:nvSpPr>
+          <p:cNvPr id="14" name="Oval 13"/>
+          <p:cNvSpPr/>
+          <p:nvPr/>
+        </p:nvSpPr>
+        <p:spPr>
+          <a:xfrm>
+            <a:off x="859536" y="4498848"/>
+            <a:ext cx="182880" cy="182880"/>
+          </a:xfrm>
+          <a:prstGeom prst="ellipse">
+            <a:avLst/>
+          </a:prstGeom>
+          <a:solidFill>
+            <a:srgbClr val="F5A623"/>
+          </a:solidFill>
+          <a:ln>
+            <a:noFill/>
+          </a:ln>
+          <a:effectLst/>
+        </p:spPr>
+        <p:style>
+          <a:lnRef idx="1">
+            <a:schemeClr val="accent1"/>
+          </a:lnRef>
+          <a:fillRef idx="3">
+            <a:schemeClr val="accent1"/>
+          </a:fillRef>
+          <a:effectRef idx="2">
+            <a:schemeClr val="accent1"/>
+          </a:effectRef>
+          <a:fontRef idx="minor">
+            <a:schemeClr val="lt1"/>
+          </a:fontRef>
+        </p:style>
+        <p:txBody>
+          <a:bodyPr rtlCol="0" anchor="ctr"/>
+          <a:lstStyle/>
+          <a:p>
+            <a:pPr algn="ctr"/>
+          </a:p>
+        </p:txBody>
+      </p:sp>
+      <p:sp>
+        <p:nvSpPr>
+          <p:cNvPr id="15" name="TextBox 14"/>
+          <p:cNvSpPr txBox="1"/>
+          <p:nvPr/>
+        </p:nvSpPr>
+        <p:spPr>
+          <a:xfrm>
+            <a:off x="1170432" y="4425696"/>
+            <a:ext cx="4439412" cy="457200"/>
+          </a:xfrm>
+          <a:prstGeom prst="rect">
+            <a:avLst/>
+          </a:prstGeom>
+          <a:noFill/>
+        </p:spPr>
+        <p:txBody>
+          <a:bodyPr wrap="square" anchor="ctr" lIns="0" rIns="0" tIns="0" bIns="0">
+            <a:spAutoFit/>
+          </a:bodyPr>
+          <a:lstStyle/>
+          <a:p>
+            <a:pPr algn="l"/>
+            <a:r>
+              <a:rPr sz="1200" b="1" i="0">
+                <a:solidFill>
+                  <a:srgbClr val="F5A623"/>
+                </a:solidFill>
+                <a:latin typeface="Trebuchet MS"/>
+              </a:rPr>
+              <a:t>3</a:t>
+            </a:r>
+            <a:r>
+              <a:rPr sz="1600" b="1" i="0">
+                <a:solidFill>
+                  <a:srgbClr val="EDEDED"/>
+                </a:solidFill>
+                <a:latin typeface="Trebuchet MS"/>
+              </a:rPr>
+              <a:t>  Next-Best-Action (NBA)</a:t>
+            </a:r>
+          </a:p>
+        </p:txBody>
+      </p:sp>
+      <p:sp>
+        <p:nvSpPr>
+          <p:cNvPr id="16" name="TextBox 15"/>
+          <p:cNvSpPr txBox="1"/>
+          <p:nvPr/>
+        </p:nvSpPr>
+        <p:spPr>
+          <a:xfrm>
+            <a:off x="877824" y="5029200"/>
+            <a:ext cx="4750307" cy="914400"/>
+          </a:xfrm>
+          <a:prstGeom prst="rect">
+            <a:avLst/>
+          </a:prstGeom>
+          <a:noFill/>
+        </p:spPr>
+        <p:txBody>
+          <a:bodyPr wrap="square" anchor="t" lIns="0" rIns="0" tIns="0" bIns="0">
+            <a:spAutoFit/>
+          </a:bodyPr>
+          <a:lstStyle/>
+          <a:p>
+            <a:pPr algn="l">
+              <a:lnSpc>
+                <a:spcPct val="106000"/>
+              </a:lnSpc>
+            </a:pPr>
+            <a:r>
+              <a:rPr sz="1250" b="0" i="0">
+                <a:solidFill>
+                  <a:srgbClr val="9A9AA6"/>
+                </a:solidFill>
+                <a:latin typeface="Calibri"/>
+              </a:rPr>
+              <a:t>Mensagem por template governado + próximo passo (SIMULATE_LOAN, OPEN_DEPOSIT). Nunca texto livre do LLM.</a:t>
+            </a:r>
+          </a:p>
+        </p:txBody>
+      </p:sp>
+      <p:sp>
+        <p:nvSpPr>
+          <p:cNvPr id="17" name="Rounded Rectangle 16"/>
+          <p:cNvSpPr/>
+          <p:nvPr/>
+        </p:nvSpPr>
+        <p:spPr>
+          <a:xfrm>
+            <a:off x="6268212" y="4187952"/>
+            <a:ext cx="5353812" cy="1847088"/>
+          </a:xfrm>
+          <a:prstGeom prst="roundRect">
+            <a:avLst>
+              <a:gd name="adj" fmla="val 6000"/>
+            </a:avLst>
+          </a:prstGeom>
+          <a:solidFill>
+            <a:srgbClr val="0C0C0E"/>
+          </a:solidFill>
+          <a:ln w="12700">
+            <a:solidFill>
+              <a:srgbClr val="2A2A30"/>
+            </a:solidFill>
+          </a:ln>
+          <a:effectLst/>
+        </p:spPr>
+        <p:style>
+          <a:lnRef idx="1">
+            <a:schemeClr val="accent1"/>
+          </a:lnRef>
+          <a:fillRef idx="3">
+            <a:schemeClr val="accent1"/>
+          </a:fillRef>
+          <a:effectRef idx="2">
+            <a:schemeClr val="accent1"/>
+          </a:effectRef>
+          <a:fontRef idx="minor">
+            <a:schemeClr val="lt1"/>
+          </a:fontRef>
+        </p:style>
+        <p:txBody>
+          <a:bodyPr rtlCol="0" anchor="ctr"/>
+          <a:lstStyle/>
+          <a:p>
+            <a:pPr algn="ctr"/>
+          </a:p>
+        </p:txBody>
+      </p:sp>
+      <p:sp>
+        <p:nvSpPr>
+          <p:cNvPr id="18" name="Oval 17"/>
+          <p:cNvSpPr/>
+          <p:nvPr/>
+        </p:nvSpPr>
+        <p:spPr>
+          <a:xfrm>
+            <a:off x="6560820" y="4498848"/>
+            <a:ext cx="182880" cy="182880"/>
+          </a:xfrm>
+          <a:prstGeom prst="ellipse">
+            <a:avLst/>
+          </a:prstGeom>
+          <a:solidFill>
+            <a:srgbClr val="3291FF"/>
+          </a:solidFill>
+          <a:ln>
+            <a:noFill/>
+          </a:ln>
+          <a:effectLst/>
+        </p:spPr>
+        <p:style>
+          <a:lnRef idx="1">
+            <a:schemeClr val="accent1"/>
+          </a:lnRef>
+          <a:fillRef idx="3">
+            <a:schemeClr val="accent1"/>
+          </a:fillRef>
+          <a:effectRef idx="2">
+            <a:schemeClr val="accent1"/>
+          </a:effectRef>
+          <a:fontRef idx="minor">
+            <a:schemeClr val="lt1"/>
+          </a:fontRef>
+        </p:style>
+        <p:txBody>
+          <a:bodyPr rtlCol="0" anchor="ctr"/>
+          <a:lstStyle/>
+          <a:p>
+            <a:pPr algn="ctr"/>
+          </a:p>
+        </p:txBody>
+      </p:sp>
+      <p:sp>
+        <p:nvSpPr>
+          <p:cNvPr id="19" name="TextBox 18"/>
+          <p:cNvSpPr txBox="1"/>
+          <p:nvPr/>
+        </p:nvSpPr>
+        <p:spPr>
+          <a:xfrm>
+            <a:off x="6871716" y="4425696"/>
+            <a:ext cx="4439412" cy="457200"/>
+          </a:xfrm>
+          <a:prstGeom prst="rect">
+            <a:avLst/>
+          </a:prstGeom>
+          <a:noFill/>
+        </p:spPr>
+        <p:txBody>
+          <a:bodyPr wrap="square" anchor="ctr" lIns="0" rIns="0" tIns="0" bIns="0">
+            <a:spAutoFit/>
+          </a:bodyPr>
+          <a:lstStyle/>
+          <a:p>
+            <a:pPr algn="l"/>
+            <a:r>
+              <a:rPr sz="1200" b="1" i="0">
+                <a:solidFill>
+                  <a:srgbClr val="3291FF"/>
+                </a:solidFill>
+                <a:latin typeface="Trebuchet MS"/>
+              </a:rPr>
+              <a:t>4</a:t>
+            </a:r>
+            <a:r>
+              <a:rPr sz="1600" b="1" i="0">
+                <a:solidFill>
+                  <a:srgbClr val="EDEDED"/>
+                </a:solidFill>
+                <a:latin typeface="Trebuchet MS"/>
+              </a:rPr>
+              <a:t>  IA responsável</a:t>
+            </a:r>
+          </a:p>
+        </p:txBody>
+      </p:sp>
+      <p:sp>
+        <p:nvSpPr>
+          <p:cNvPr id="20" name="TextBox 19"/>
+          <p:cNvSpPr txBox="1"/>
+          <p:nvPr/>
+        </p:nvSpPr>
+        <p:spPr>
+          <a:xfrm>
+            <a:off x="6579107" y="5029200"/>
+            <a:ext cx="4750307" cy="914400"/>
+          </a:xfrm>
+          <a:prstGeom prst="rect">
+            <a:avLst/>
+          </a:prstGeom>
+          <a:noFill/>
+        </p:spPr>
+        <p:txBody>
+          <a:bodyPr wrap="square" anchor="t" lIns="0" rIns="0" tIns="0" bIns="0">
+            <a:spAutoFit/>
+          </a:bodyPr>
+          <a:lstStyle/>
+          <a:p>
+            <a:pPr algn="l">
+              <a:lnSpc>
+                <a:spcPct val="106000"/>
+              </a:lnSpc>
+            </a:pPr>
+            <a:r>
+              <a:rPr sz="1250" b="0" i="0">
+                <a:solidFill>
+                  <a:srgbClr val="9A9AA6"/>
+                </a:solidFill>
+                <a:latin typeface="Calibri"/>
+              </a:rPr>
+              <a:t>Atributos protegidos + fairness por grupo: exposição 0,00 · valor 0,24 (≤30) — suitability, auditado, nunca decide.</a:t>
+            </a:r>
+          </a:p>
+        </p:txBody>
+      </p:sp>
+      <p:sp>
+        <p:nvSpPr>
+          <p:cNvPr id="21" name="TextBox 20"/>
+          <p:cNvSpPr txBox="1"/>
+          <p:nvPr/>
+        </p:nvSpPr>
+        <p:spPr>
+          <a:xfrm>
+            <a:off x="566928" y="6437376"/>
+            <a:ext cx="4572000" cy="274320"/>
+          </a:xfrm>
+          <a:prstGeom prst="rect">
+            <a:avLst/>
+          </a:prstGeom>
+          <a:noFill/>
+        </p:spPr>
+        <p:txBody>
+          <a:bodyPr wrap="square" anchor="t" lIns="0" rIns="0" tIns="0" bIns="0">
+            <a:spAutoFit/>
+          </a:bodyPr>
+          <a:lstStyle/>
+          <a:p>
+            <a:pPr algn="l"/>
+            <a:r>
+              <a:rPr sz="850" b="0" i="0" spc="200">
+                <a:solidFill>
+                  <a:srgbClr val="5A5A63"/>
+                </a:solidFill>
+                <a:latin typeface="Consolas"/>
+              </a:rPr>
+              <a:t>ADAPTIVE OFFERS PLATFORM</a:t>
+            </a:r>
+          </a:p>
+        </p:txBody>
+      </p:sp>
+      <p:sp>
+        <p:nvSpPr>
+          <p:cNvPr id="22" name="TextBox 21"/>
+          <p:cNvSpPr txBox="1"/>
+          <p:nvPr/>
+        </p:nvSpPr>
+        <p:spPr>
+          <a:xfrm>
+            <a:off x="7050024" y="6437376"/>
+            <a:ext cx="4572000" cy="274320"/>
+          </a:xfrm>
+          <a:prstGeom prst="rect">
+            <a:avLst/>
+          </a:prstGeom>
+          <a:noFill/>
+        </p:spPr>
+        <p:txBody>
+          <a:bodyPr wrap="square" anchor="t" lIns="0" rIns="0" tIns="0" bIns="0">
+            <a:spAutoFit/>
+          </a:bodyPr>
+          <a:lstStyle/>
+          <a:p>
+            <a:pPr algn="r"/>
+            <a:r>
+              <a:rPr sz="850" b="0" i="0" spc="200">
+                <a:solidFill>
+                  <a:srgbClr val="5A5A63"/>
+                </a:solidFill>
+                <a:latin typeface="Consolas"/>
+              </a:rPr>
+              <a:t>GRUPO 74 · FIAP PÓS-TECH 7MLET</a:t>
+            </a:r>
+          </a:p>
+        </p:txBody>
+      </p:sp>
+      <p:sp>
+        <p:nvSpPr>
+          <p:cNvPr id="23" name="TextBox 22"/>
+          <p:cNvSpPr txBox="1"/>
+          <p:nvPr/>
+        </p:nvSpPr>
+        <p:spPr>
+          <a:xfrm>
+            <a:off x="5820156" y="6437376"/>
+            <a:ext cx="548640" cy="274320"/>
+          </a:xfrm>
+          <a:prstGeom prst="rect">
+            <a:avLst/>
+          </a:prstGeom>
+          <a:noFill/>
+        </p:spPr>
+        <p:txBody>
+          <a:bodyPr wrap="square" anchor="t" lIns="0" rIns="0" tIns="0" bIns="0">
+            <a:spAutoFit/>
+          </a:bodyPr>
+          <a:lstStyle/>
+          <a:p>
+            <a:pPr algn="ctr"/>
+            <a:r>
+              <a:rPr sz="850" b="1" i="0">
+                <a:solidFill>
+                  <a:srgbClr val="0070F3"/>
+                </a:solidFill>
+                <a:latin typeface="Consolas"/>
+              </a:rPr>
+              <a:t>08</a:t>
+            </a:r>
+          </a:p>
+        </p:txBody>
+      </p:sp>
+    </p:spTree>
+  </p:cSld>
+  <p:clrMapOvr>
+    <a:masterClrMapping/>
+  </p:clrMapOvr>
+</p:sld>
+</file>
+
 <file path=ppt/slides/slide3.xml><?xml version="1.0" encoding="utf-8"?>
 <p:sld xmlns:a="http://schemas.openxmlformats.org/drawingml/2006/main" xmlns:r="http://schemas.openxmlformats.org/officeDocument/2006/relationships" xmlns:p="http://schemas.openxmlformats.org/presentationml/2006/main">
   <p:cSld name="Slide 3">
@@ -25095,7 +26068,7 @@
                 <a:ea typeface="Consolas" pitchFamily="34" charset="-122"/>
                 <a:cs typeface="Consolas" pitchFamily="34" charset="-120"/>
               </a:rPr>
-              <a:t>08</a:t>
+              <a:t>09</a:t>
             </a:r>
             <a:endParaRPr lang="en-US" sz="850" dirty="0"/>
           </a:p>
@@ -26225,7 +27198,7 @@
                 <a:ea typeface="Consolas" pitchFamily="34" charset="-122"/>
                 <a:cs typeface="Consolas" pitchFamily="34" charset="-120"/>
               </a:rPr>
-              <a:t>09</a:t>
+              <a:t>10</a:t>
             </a:r>
             <a:endParaRPr lang="en-US" sz="850" dirty="0"/>
           </a:p>

</xml_diff>